<commit_message>
SGD: guion serverless — lámina 7 reescrita (isolates de V8 explicado más simple)
Co-Authored-By: Claude Opus 5.5 <noreply@anthropic.com>
</commit_message>
<xml_diff>
--- a/materias/SGD/entregables/serverless/presentacion-serverless.pptx
+++ b/materias/SGD/entregables/serverless/presentacion-serverless.pptx
@@ -120,7 +120,7 @@
   <p:extLst>
     <p:ext uri="{521415D9-36F7-43E2-AB2F-B90AF26B5E84}">
       <p14:sectionLst xmlns:p14="http://schemas.microsoft.com/office/powerpoint/2010/main">
-        <p14:section name="Expositor 1 — Qué es" id="{670ad80a-ad7a-aada-bcd5-bf08eb7c5978}">
+        <p14:section name="Expositor 1 — Qué es" id="{b7c780c1-5914-ce1c-92a5-d5c26aae7cba}">
           <p14:sldIdLst>
             <p14:sldId id="256"/>
             <p14:sldId id="257"/>
@@ -128,21 +128,21 @@
             <p14:sldId id="259"/>
           </p14:sldIdLst>
         </p14:section>
-        <p14:section name="Expositor 2 — Cómo funciona" id="{f2a76c4a-03e3-1661-bf17-673cdb9999a5}">
+        <p14:section name="Expositor 2 — Cómo funciona" id="{06f21479-7983-ac3b-72e0-ecbfffd982cc}">
           <p14:sldIdLst>
             <p14:sldId id="260"/>
             <p14:sldId id="261"/>
             <p14:sldId id="262"/>
           </p14:sldIdLst>
         </p14:section>
-        <p14:section name="Expositor 3 — Economía y datos" id="{0e6ed689-6f97-439c-c50d-9740ce55d633}">
+        <p14:section name="Expositor 3 — Economía y datos" id="{abd229d6-2267-f80b-191b-ecd591b9f995}">
           <p14:sldIdLst>
             <p14:sldId id="263"/>
             <p14:sldId id="264"/>
             <p14:sldId id="265"/>
           </p14:sldIdLst>
         </p14:section>
-        <p14:section name="Expositor 4 — Límites y futuro" id="{79581a35-209e-37ec-61c1-a311bca2731c}">
+        <p14:section name="Expositor 4 — Límites y futuro" id="{bcdcde98-8d23-4efd-8646-b0fbc003b1df}">
           <p14:sldIdLst>
             <p14:sldId id="266"/>
             <p14:sldId id="267"/>
@@ -1347,7 +1347,9 @@
             <a:r>
               <a:rPr lang="en-US" dirty="0"/>
               <a:t>[Expositor 1 · 0:20]
-Buenas. Somos el grupo que va a presentar serverless. Vamos a contar qué es, cómo funciona por dentro, cuánto cuesta de verdad y, sobre todo, cuándo no conviene usarlo. Somos cuatro y nos vamos a ir pasando la palabra por bloques.</a:t>
+ Buenas. Somos el grupo que va a presentar serverless. Vamos a contar qué es,
+ cómo funciona por dentro, cuánto cuesta de verdad y, sobre todo, cuándo no
+ conviene usarlo. Somos cuatro y nos vamos a ir pasando la palabra por bloques.</a:t>
             </a:r>
             <a:endParaRPr lang="en-US" dirty="0"/>
           </a:p>
@@ -1436,9 +1438,19 @@
             <a:r>
               <a:rPr lang="en-US" dirty="0"/>
               <a:t>[Expositor 3 · 1:15]
-Esto es lo que más se conecta con la materia. Para que una base de datos sea serverless, tiene que poder apagar el cómputo sin perder los datos. El truco es separar las dos cosas: los datos viven en un almacenamiento persistente, y los nodos que procesan consultas se prenden y se apagan según la demanda. Así funcionan Neon, Aurora Serverless y DynamoDB en modo on demand.
-Pero hay un choque clásico. Una base relacional como Postgres soporta cientos de conexiones, no miles. Si quinientas funciones corren a la vez y cada una abre su conexión, la base se cae. Las soluciones son dos: poner un pooler en el medio, como RDS Proxy o PgBouncer, que reutiliza pocas conexiones para muchas funciones, o usar bases que se consultan por HTTP en lugar de mantener conexiones abiertas.
-Pase al expositor 4: con todo esto ya podemos decir cuándo conviene y cuándo no.</a:t>
+ Esto es lo que más se conecta con la materia. Para que una base de datos sea
+ serverless, tiene que poder apagar el cómputo sin perder los datos. El truco es
+ separar las dos cosas: los datos viven en un almacenamiento persistente, y los
+ nodos que procesan consultas se prenden y se apagan según la demanda. Así
+ funcionan Neon, Aurora Serverless y DynamoDB en modo on demand.
+ Pero hay un choque clásico. Una base relacional como Postgres soporta cientos
+ de conexiones, no miles. Si quinientas funciones corren a la vez y cada una
+ abre su conexión, la base se cae. Las soluciones son dos: poner un pooler en
+ el medio, como RDS Proxy o PgBouncer, que reutiliza pocas conexiones para
+ muchas funciones, o usar bases que se consultan por HTTP en lugar de mantener
+ conexiones abiertas.
+ Pase al expositor 4: con todo esto ya podemos decir cuándo conviene y cuándo
+ no.</a:t>
             </a:r>
             <a:endParaRPr lang="en-US" dirty="0"/>
           </a:p>
@@ -1527,8 +1539,17 @@
             <a:r>
               <a:rPr lang="en-US" dirty="0"/>
               <a:t>[Expositor 4 · 1:00]
-Juntando todo lo anterior, serverless encaja cuando la carga es espigada o impredecible, cuando el trabajo se dispara por eventos y cuando no hace falta guardar estado entre pedidos. Por ejemplo, generar una miniatura cada vez que alguien sube una foto, procesar datos de sensores o correr tareas programadas. iRobot, el de la Roomba, procesa más de veinte millones de eventos por día así y reporta un treinta por ciento menos de costo.
-No encaja cuando la carga es constante, porque ya vimos que arriba de un tercio de uso pierde. Tampoco cuando la latencia es crítica, por el cold start, cuando hace falta estado o conexiones persistentes, o cuando el sistema es una cadena larga de funciones muy acopladas. El caso más famoso de eso lo contó el propio Amazon.</a:t>
+ Juntando todo lo anterior, serverless encaja cuando la carga es espigada o
+ impredecible, cuando el trabajo se dispara por eventos y cuando no hace falta
+ guardar estado entre pedidos. Por ejemplo, generar una miniatura cada vez que
+ alguien sube una foto, procesar datos de sensores o correr tareas programadas.
+ iRobot, el de la Roomba, procesa más de veinte millones de eventos por día así
+ y reporta un treinta por ciento menos de costo.
+ No encaja cuando la carga es constante, porque ya vimos que arriba de un
+ tercio de uso pierde. Tampoco cuando la latencia es crítica, por el cold
+ start, cuando hace falta estado o conexiones persistentes, o cuando el sistema
+ es una cadena larga de funciones muy acopladas. El caso más famoso de eso lo
+ contó el propio Amazon.</a:t>
             </a:r>
             <a:endParaRPr lang="en-US" dirty="0"/>
           </a:p>
@@ -1617,9 +1638,15 @@
             <a:r>
               <a:rPr lang="en-US" dirty="0"/>
               <a:t>[Expositor 4 · 1:00]
-En 2023, el equipo de Prime Video publicó que había sacado un sistema de serverless y había bajado el costo un noventa por ciento.
-El sistema analizaba la calidad de cada stream que miraban los usuarios. Estaba armado con funciones encadenadas, y por cada segundo de video había varias transiciones entre funciones. Además, los datos pasaban de una etapa a otra por la red. Lo que más costaba no era procesar: era mover datos. Lo reescribieron como un solo proceso en contenedores, con todo junto en memoria.
-La lección no es que serverless sea malo. Es que, cuando comunicar cuesta más que computar, hay que juntar los componentes, no separarlos.</a:t>
+ En 2023, el equipo de Prime Video publicó que había sacado un sistema de
+ serverless y había bajado el costo un noventa por ciento.
+ El sistema analizaba la calidad de cada stream que miraban los usuarios. Estaba
+ armado con funciones encadenadas, y por cada segundo de video había varias
+ transiciones entre funciones. Además, los datos pasaban de una etapa a otra
+ por la red. Lo que más costaba no era procesar: era mover datos. Lo
+ reescribieron como un solo proceso en contenedores, con todo junto en memoria.
+ La lección no es que serverless sea malo. Es que, cuando comunicar cuesta más
+ que computar, hay que juntar los componentes, no separarlos.</a:t>
             </a:r>
             <a:endParaRPr lang="en-US" dirty="0"/>
           </a:p>
@@ -1708,8 +1735,14 @@
             <a:r>
               <a:rPr lang="en-US" dirty="0"/>
               <a:t>[Expositor 4 · 0:50]
-Y la industria tomó nota. En 2026 Amazon lanzó Lambda Managed Instances: las mismas funciones, pero corriendo sobre servidores dedicados, pensado para cargas estables. Es el propio proveedor reconociendo el punto de cruce. También anunció microVMs con sesiones de hasta ocho horas y estado, que rompen dos de los dogmas originales.
-En paralelo, la inferencia de inteligencia artificial se está llevando al edge, cerca del usuario. Y dos de cada tres empresas que usan funciones también usan contenedores. El futuro es híbrido: cada carga va donde le conviene.</a:t>
+ Y la industria tomó nota. En 2026 Amazon lanzó Lambda Managed Instances: las
+ mismas funciones, pero corriendo sobre servidores dedicados, pensado para
+ cargas estables. Es el propio proveedor reconociendo el punto de cruce. También
+ anunció microVMs con sesiones de hasta ocho horas y estado, que rompen dos de
+ los dogmas originales.
+ En paralelo, la inferencia de inteligencia artificial se está llevando al
+ edge, cerca del usuario. Y dos de cada tres empresas que usan funciones también
+ usan contenedores. El futuro es híbrido: cada carga va donde le conviene.</a:t>
             </a:r>
             <a:endParaRPr lang="en-US" dirty="0"/>
           </a:p>
@@ -1798,7 +1831,10 @@
             <a:r>
               <a:rPr lang="en-US" dirty="0"/>
               <a:t>[Expositor 4 · 0:40]
-Para cerrar, tres ideas. Serverless no es sin servidores: es no tener que administrarlos. Se paga por uso, así que gana en cargas espigadas y pierde cuando el uso es alto y constante. Y es un trade-off: se elige porque encaja con el problema, no porque esté de moda. Gracias. ¿Preguntas?</a:t>
+ Para cerrar, tres ideas. Serverless no es sin servidores: es no tener que
+ administrarlos. Se paga por uso, así que gana en cargas espigadas y pierde
+ cuando el uso es alto y constante. Y es un trade-off: se elige porque encaja
+ con el problema, no porque esté de moda. Gracias. ¿Preguntas?</a:t>
             </a:r>
             <a:endParaRPr lang="en-US" dirty="0"/>
           </a:p>
@@ -1887,8 +1923,18 @@
             <a:r>
               <a:rPr lang="en-US" dirty="0"/>
               <a:t>[Expositor 1 · 1:00]
-Arranquemos por el nombre, que es lo primero que confunde. Serverless no significa que no haya servidores. Los servidores existen, están en un datacenter y alguien los mantiene. La diferencia es que ese alguien no sos vos: es el proveedor. Pasa lo mismo con wireless: los cables siguen existiendo, pero no los tirás vos.
-Y no es una moda de nicho. Lambda, el servicio serverless de Amazon, ejecuta más de quince billones de invocaciones por mes, billones de los nuestros, diez a la doce. Según el relevamiento de Datadog de 2025, el sesenta y cinco por ciento de los clientes de AWS usa Lambda y el setenta por ciento de los de Google Cloud usa Cloud Run. O sea, es algo que la mayoría de las empresas que están en la nube ya usa en producción. Entonces, si los servidores existen, ¿qué es exactamente lo que cambia?</a:t>
+ Arranquemos por el nombre, que es lo primero que confunde. Serverless no
+ significa que no haya servidores. Los servidores existen, están en un
+ datacenter y alguien los mantiene. La diferencia es que ese alguien no sos vos:
+ es el proveedor. Pasa lo mismo con wireless: los cables siguen existiendo, pero
+ no los tirás vos.
+ Y no es una moda de nicho. Lambda, el servicio serverless de Amazon, ejecuta
+ más de quince billones de invocaciones por mes, billones de los nuestros, diez a
+ la doce. Según el relevamiento de Datadog de 2025, el sesenta y cinco por
+ ciento de los clientes de AWS usa Lambda y el setenta por ciento de los de
+ Google Cloud usa Cloud Run. O sea, es algo que la mayoría de las empresas que
+ están en la nube ya usa en producción. Entonces, si los servidores existen,
+ ¿qué es exactamente lo que cambia?</a:t>
             </a:r>
             <a:endParaRPr lang="en-US" dirty="0"/>
           </a:p>
@@ -1977,9 +2023,18 @@
             <a:r>
               <a:rPr lang="en-US" dirty="0"/>
               <a:t>[Expositor 1 · 1:00]
-La definición que tomamos es la de la CNCF, la fundación que agrupa los proyectos cloud native. Dice que serverless es construir y correr aplicaciones que no requieren gestión de servidores, y que se ejecutan, escalan y facturan según la demanda exacta del momento.
-De ahí salen tres propiedades, y las usamos como criterio. Primera: no administrás infraestructura. No elegís el tamaño de la máquina, no parcheás el sistema operativo. Segunda: escala hasta cero. Si llegan mil pedidos levanta lo necesario, y si no llega ninguno, no queda nada corriendo. Tercera: pagás por uso real, por ejecución, no por tener algo encendido.
-Si falta una, no es serverless. Un Kubernetes administrado por el proveedor cumple la primera a medias, pero no la tercera: el pod cuesta plata aunque nadie lo llame.</a:t>
+ La definición que tomamos es la de la CNCF, la fundación que agrupa los
+ proyectos cloud native. Dice que serverless es construir y correr aplicaciones
+ que no requieren gestión de servidores, y que se ejecutan, escalan y facturan
+ según la demanda exacta del momento.
+ De ahí salen tres propiedades, y las usamos como criterio. Primera: no
+ administrás infraestructura. No elegís el tamaño de la máquina, no parcheás el
+ sistema operativo. Segunda: escala hasta cero. Si llegan mil pedidos levanta lo
+ necesario, y si no llega ninguno, no queda nada corriendo. Tercera: pagás por
+ uso real, por ejecución, no por tener algo encendido.
+ Si falta una, no es serverless. Un Kubernetes administrado por el proveedor
+ cumple la primera a medias, pero no la tercera: el pod cuesta plata aunque
+ nadie lo llame.</a:t>
             </a:r>
             <a:endParaRPr lang="en-US" dirty="0"/>
           </a:p>
@@ -2068,11 +2123,22 @@
             <a:r>
               <a:rPr lang="en-US" dirty="0"/>
               <a:t>[Expositor 1 · 1:10]
-Para entender por qué apareció esto, sirve mirar la historia como una escalera. En cada escalón el desarrollador se desentiende de una capa más.
-Con bare metal comprás el servidor y te ocupás de todo. Con IaaS, por ejemplo EC2, alquilás una máquina virtual por hora. Con PaaS subís tu aplicación y el proveedor se ocupa del sistema operativo. Con contenedores empaquetás la aplicación con sus dependencias. Y en el último escalón, FaaS, lo que desplegás es una sola función.
-Fíjense en la última fila: la unidad de cobro pasa de la hora al milisegundo. Es la primera vez que el costo de cómputo puede ser cero cuando nadie usa el sistema.
-Abajo está la otra distinción importante. FaaS es tu código: funciones que se disparan con eventos. BaaS son servicios que consumís por API, como la base, la autenticación o el almacenamiento. En una aplicación serverless real, la mayor parte es BaaS, y tus funciones son el pegamento entre esos servicios.
-Pase al expositor 2: ahora que sabemos qué es, veamos qué pasa por dentro cuando llega un pedido.</a:t>
+ Para entender por qué apareció esto, sirve mirar la historia como una escalera.
+ En cada escalón el desarrollador se desentiende de una capa más.
+ Con bare metal comprás el servidor y te ocupás de todo. Con IaaS, por ejemplo
+ EC2, alquilás una máquina virtual por hora. Con PaaS subís tu aplicación y el
+ proveedor se ocupa del sistema operativo. Con contenedores empaquetás la
+ aplicación con sus dependencias. Y en el último escalón, FaaS, lo que desplegás
+ es una sola función.
+ Fíjense en la última fila: la unidad de cobro pasa de la hora al milisegundo.
+ Es la primera vez que el costo de cómputo puede ser cero cuando nadie usa el
+ sistema.
+ Abajo está la otra distinción importante. FaaS es tu código: funciones que se
+ disparan con eventos. BaaS son servicios que consumís por API, como la base, la
+ autenticación o el almacenamiento. En una aplicación serverless real, la mayor
+ parte es BaaS, y tus funciones son el pegamento entre esos servicios.
+ Pase al expositor 2: ahora que sabemos qué es, veamos qué pasa por dentro
+ cuando llega un pedido.</a:t>
             </a:r>
             <a:endParaRPr lang="en-US" dirty="0"/>
           </a:p>
@@ -2161,9 +2227,21 @@
             <a:r>
               <a:rPr lang="en-US" dirty="0"/>
               <a:t>[Expositor 2 · 1:20]
-Una función serverless no está corriendo todo el tiempo esperando. Se invoca cuando pasa algo: llega un pedido HTTP, alguien sube un archivo, entra un mensaje a una cola o se cumple un horario.
-La primera vez, la plataforma tiene que preparar el entorno. Esa fase se llama INIT: crea una máquina virtual chiquita, descarga el código, arranca el runtime y corre el código de inicialización, que es donde van los imports y la conexión a la base. Después viene INVOKE, que ejecuta la función propiamente dicha. Al terminar, el entorno no se destruye: se congela. Si llega otro pedido, se reutiliza y se saltea todo el INIT. Si pasan entre cinco y quince minutos sin pedidos, se apaga.
-De esto salen dos consecuencias. La primera: el estado no se puede guardar en memoria, porque no hay garantía de que dos pedidos caigan en el mismo entorno. Es stateless por contrato. La segunda: en Lambda cada entorno atiende un pedido a la vez. Si llegan cien por segundo y cada uno tarda dos décimas, necesitás veinte entornos simultáneos. Si tarda dos segundos, necesitás doscientos.</a:t>
+ Una función serverless no está corriendo todo el tiempo esperando. Se invoca
+ cuando pasa algo: llega un pedido HTTP, alguien sube un archivo, entra un
+ mensaje a una cola o se cumple un horario.
+ La primera vez, la plataforma tiene que preparar el entorno. Esa fase se llama
+ INIT: crea una máquina virtual chiquita, descarga el código, arranca el runtime
+ y corre el código de inicialización, que es donde van los imports y la conexión
+ a la base. Después viene INVOKE, que ejecuta la función propiamente dicha. Al
+ terminar, el entorno no se destruye: se congela. Si llega otro pedido, se
+ reutiliza y se saltea todo el INIT. Si pasan entre cinco y quince minutos sin
+ pedidos, se apaga.
+ De esto salen dos consecuencias. La primera: el estado no se puede guardar en
+ memoria, porque no hay garantía de que dos pedidos caigan en el mismo entorno.
+ Es stateless por contrato. La segunda: en Lambda cada entorno atiende un pedido
+ a la vez. Si llegan cien por segundo y cada uno tarda dos décimas, necesitás
+ veinte entornos simultáneos. Si tarda dos segundos, necesitás doscientos.</a:t>
             </a:r>
             <a:endParaRPr lang="en-US" dirty="0"/>
           </a:p>
@@ -2252,9 +2330,20 @@
             <a:r>
               <a:rPr lang="en-US" dirty="0"/>
               <a:t>[Expositor 2 · 1:10]
-Esa primera invocación, la que tiene que pasar por INIT, es más lenta. Se llama cold start y es el precio de poder escalar a cero: si no hay nada corriendo, algo hay que arrancar.
-Cuánto tarda depende mucho del lenguaje. Go o Rust, que son compilados, arrancan en menos de cien milisegundos. Python anda entre doscientos y cuatrocientos. Java sin optimizar puede tardar segundos. Si además la función está dentro de una red privada, se suman unos cientos de milisegundos más. Estos números son órdenes de magnitud reportados en 2026, no mediciones nuestras.
-Para bajarlo hay varias opciones. Provisioned Concurrency mantiene entornos precalentados, pero se pagan por hora, así que se pierde parte del pago por uso. SnapStart, en vez de arrancar de cero, restaura una foto de un entorno ya inicializado: así Java baja a unos cien milisegundos. Y siempre ayuda tener un paquete liviano, con pocas dependencias.</a:t>
+ Esa primera invocación, la que tiene que pasar por INIT, es más lenta. Se llama
+ cold start y es el precio de poder escalar a cero: si no hay nada corriendo,
+ algo hay que arrancar.
+ Cuánto tarda depende mucho del lenguaje. Go o Rust, que son compilados,
+ arrancan en menos de cien milisegundos. Python anda entre doscientos y
+ cuatrocientos. Java sin optimizar puede tardar segundos. Si además la función
+ está dentro de una red privada, se suman unos cientos de milisegundos más.
+ Estos números son órdenes de magnitud reportados en 2026, no mediciones
+ nuestras.
+ Para bajarlo hay varias opciones. Provisioned Concurrency mantiene entornos
+ precalentados, pero se pagan por hora, así que se pierde parte del pago por
+ uso. SnapStart, en vez de arrancar de cero, restaura una foto de un entorno ya
+ inicializado: así Java baja a unos cien milisegundos. Y siempre ayuda tener un
+ paquete liviano, con pocas dependencias.</a:t>
             </a:r>
             <a:endParaRPr lang="en-US" dirty="0"/>
           </a:p>
@@ -2342,11 +2431,28 @@
           <a:p>
             <a:r>
               <a:rPr lang="en-US" dirty="0"/>
-              <a:t>[Expositor 2 · 1:15]
-Ahora, el problema que tiene el proveedor es difícil: correr código de miles de clientes distintos en la misma máquina física, sin que uno pueda ver al otro, y arrancando en milisegundos. Los contenedores solos no alcanzan, porque comparten el kernel. Las máquinas virtuales tradicionales son demasiado lentas.
-Amazon lo resolvió con Firecracker, un monitor de máquinas virtuales escrito en Rust y open source. Levanta una microVM con Linux en menos de ciento veinticinco milisegundos y con unos cinco megas de memoria extra. Lo logra sacando todo lo que una PC normal trae y una función no necesita. El aislamiento es por hardware. Es la base de Lambda.
-Cloudflare tomó el camino opuesto: isolates de V8, el motor de JavaScript de Chrome. Un solo proceso aloja miles de funciones aisladas entre sí. Arrancan unas cien veces más rápido que un proceso de Node, así que el cold start prácticamente desaparece. El costo es que el aislamiento es por software y solo corre JavaScript o WebAssembly.
-Pase al expositor 3: todo esto tiene un costo, y ahí es donde serverless se pone interesante.</a:t>
+              <a:t>[Expositor 2 · 1:40]
+ Ahora, el problema que tiene el proveedor es difícil: correr código de miles de
+ clientes distintos en la misma máquina física, sin que uno pueda ver al otro, y
+ arrancando en milisegundos. Los contenedores solos no alcanzan, porque
+ comparten el kernel. Las máquinas virtuales tradicionales son demasiado lentas.
+ Amazon lo resolvió con Firecracker, un monitor de máquinas virtuales escrito en
+ Rust y open source. Levanta una microVM con Linux en menos de ciento veinticinco
+ milisegundos y con unos cinco megas de memoria extra. Lo logra sacando todo lo
+ que una PC normal trae y una función no necesita. El aislamiento es por
+ hardware. Es la base de Lambda.
+ Cloudflare eligió el camino opuesto. En vez de darle a cada función su propia
+ máquina virtual, mete miles de funciones dentro de un mismo programa: V8, el
+ motor que ejecuta JavaScript en Chrome. Adentro de ese programa, cada función
+ vive en un compartimento separado, que se llama isolate, con sus propias
+ variables y sin poder ver las de las demás.
+ La ventaja es la velocidad. Como el motor ya está andando, sumar una función
+ nueva es casi instantáneo: unas cien veces más rápido que arrancar un programa
+ de Node desde cero. El cold start prácticamente desaparece. La contra son dos
+ cosas: la separación entre clientes la hace el software, no el hardware, y
+ solo se puede correr JavaScript o WebAssembly.
+ Pase al expositor 3: todo esto tiene un costo, y ahí es donde serverless se
+ pone interesante.</a:t>
             </a:r>
             <a:endParaRPr lang="en-US" dirty="0"/>
           </a:p>
@@ -2435,9 +2541,18 @@
             <a:r>
               <a:rPr lang="en-US" dirty="0"/>
               <a:t>[Expositor 3 · 1:15]
-El modelo de cobro tiene dos partes. Una por cantidad de pedidos: veinte centavos de dólar por millón. Otra por duración, medida en gigabyte-segundo, que es la memoria que configuraste multiplicada por el tiempo que corrió la función. Se cobra al milisegundo, y hay una capa gratuita todos los meses de un millón de pedidos y cuatrocientos mil gigabyte-segundo.
-Un detalle: la CPU que te dan es proporcional a la memoria. Si duplicás la memoria, la función puede terminar en la mitad del tiempo y costar lo mismo.
-Hicimos la cuenta con un caso concreto: una API con cinco millones de pedidos por mes, doscientos milisegundos cada uno y medio giga de memoria. Descontando la capa gratuita da unos dos dólares y medio por mes. Una máquina virtual chica de Amazon, encendida todo el mes, cuesta unos quince. Para este caso serverless sale seis veces más barato.</a:t>
+ El modelo de cobro tiene dos partes. Una por cantidad de pedidos: veinte
+ centavos de dólar por millón. Otra por duración, medida en gigabyte-segundo,
+ que es la memoria que configuraste multiplicada por el tiempo que corrió la
+ función. Se cobra al milisegundo, y hay una capa gratuita todos los meses de
+ un millón de pedidos y cuatrocientos mil gigabyte-segundo.
+ Un detalle: la CPU que te dan es proporcional a la memoria. Si duplicás la
+ memoria, la función puede terminar en la mitad del tiempo y costar lo mismo.
+ Hicimos la cuenta con un caso concreto: una API con cinco millones de pedidos
+ por mes, doscientos milisegundos cada uno y medio giga de memoria. Descontando
+ la capa gratuita da unos dos dólares y medio por mes. Una máquina virtual chica
+ de Amazon, encendida todo el mes, cuesta unos quince. Para este caso serverless
+ sale seis veces más barato.</a:t>
             </a:r>
             <a:endParaRPr lang="en-US" dirty="0"/>
           </a:p>
@@ -2526,10 +2641,20 @@
             <a:r>
               <a:rPr lang="en-US" dirty="0"/>
               <a:t>[Expositor 3 · 1:20]
-Pero el ejemplo anterior tiene trampa: esa API está ociosa casi todo el tiempo. ¿Qué pasa si la función corre sin parar?
-El gráfico compara el costo de tener un procesador disponible durante una hora. El servidor cuesta lo mismo esté ocupado o no: es la línea plana. Lambda, la línea naranja, arranca en cero y crece con el uso. El problema es la pendiente: normalizado por procesador, el vCPU-hora de Lambda cuesta unas tres veces más que el de una instancia equivalente.
-Las dos líneas se cruzan alrededor del treinta y cuatro por ciento de uso, un tercio. Debajo de eso gana serverless, y por mucho. Arriba, conviene un servidor.
-Es la analogía del auto: alquilar un servidor es tener auto propio, lo pagás aunque esté estacionado. Serverless es tomar un Uber: si no viajás no pagás, pero el kilómetro sale más caro. Si viajás ocho horas por día, te conviene el auto.</a:t>
+ Pero el ejemplo anterior tiene trampa: esa API está ociosa casi todo el tiempo.
+ ¿Qué pasa si la función corre sin parar?
+ El gráfico compara el costo de tener un procesador disponible durante una hora.
+ El servidor cuesta lo mismo esté ocupado o no: es la línea plana. Lambda, la
+ línea naranja, arranca en cero y crece con el uso. El problema es la
+ pendiente: normalizado por procesador, el vCPU-hora de Lambda cuesta unas tres
+ veces más que el de una instancia equivalente.
+ Las dos líneas se cruzan alrededor del treinta y cuatro por ciento de uso, un
+ tercio.
+ Debajo de eso gana serverless, y por mucho. Arriba, conviene un servidor.
+ Es la analogía del auto: alquilar un servidor es tener auto propio, lo pagás
+ aunque esté estacionado. Serverless es tomar un Uber: si no viajás no pagás,
+ pero el kilómetro sale más caro. Si viajás ocho horas por día, te conviene el
+ auto.</a:t>
             </a:r>
             <a:endParaRPr lang="en-US" dirty="0"/>
           </a:p>

</xml_diff>